<commit_message>
Omit title-slide rows that have no value yet
The deck shipped with a line reading "Team ID - [Team ID]", which looks like an
unfilled template rather than a pending field. Rows whose value is empty or
still bracketed are now dropped, so the slide reads as finished; --team-id puts
the line back once the ID is assigned.
</commit_message>
<xml_diff>
--- a/SIH2026_PS26153_Presentation.pptx
+++ b/SIH2026_PS26153_Presentation.pptx
@@ -5784,31 +5784,6 @@
                 </a:solidFill>
                 <a:latin typeface="Arial"/>
               </a:rPr>
-              <a:t>Team ID – </a:t>
-            </a:r>
-            <a:r>
-              <a:rPr sz="1300">
-                <a:solidFill>
-                  <a:srgbClr val="333F50"/>
-                </a:solidFill>
-                <a:latin typeface="Arial"/>
-              </a:rPr>
-              <a:t>[Team ID]</a:t>
-            </a:r>
-          </a:p>
-          <a:p>
-            <a:pPr>
-              <a:spcAft>
-                <a:spcPts val="700"/>
-              </a:spcAft>
-            </a:pPr>
-            <a:r>
-              <a:rPr sz="1300" b="1">
-                <a:solidFill>
-                  <a:srgbClr val="1F497D"/>
-                </a:solidFill>
-                <a:latin typeface="Arial"/>
-              </a:rPr>
               <a:t>Team Name – </a:t>
             </a:r>
             <a:r>

</xml_diff>

<commit_message>
Put team ID 261 on the title slide
Assigned today, so it becomes the default rather than a flag someone has
to remember on the morning of the presentation. Bounds, text fit and
caption overlap all still clean with the extra line on slide 1.
</commit_message>
<xml_diff>
--- a/SIH2026_PS26153_Presentation.pptx
+++ b/SIH2026_PS26153_Presentation.pptx
@@ -5784,6 +5784,31 @@
                 </a:solidFill>
                 <a:latin typeface="Arial"/>
               </a:rPr>
+              <a:t>Team ID – </a:t>
+            </a:r>
+            <a:r>
+              <a:rPr sz="1300">
+                <a:solidFill>
+                  <a:srgbClr val="333F50"/>
+                </a:solidFill>
+                <a:latin typeface="Arial"/>
+              </a:rPr>
+              <a:t>261</a:t>
+            </a:r>
+          </a:p>
+          <a:p>
+            <a:pPr>
+              <a:spcAft>
+                <a:spcPts val="700"/>
+              </a:spcAft>
+            </a:pPr>
+            <a:r>
+              <a:rPr sz="1300" b="1">
+                <a:solidFill>
+                  <a:srgbClr val="1F497D"/>
+                </a:solidFill>
+                <a:latin typeface="Arial"/>
+              </a:rPr>
               <a:t>Team Name – </a:t>
             </a:r>
             <a:r>

</xml_diff>

<commit_message>
Put the team on slide 6
Six folded-corner notes, leader first, in the strip the reference deck
uses for the same purpose. The tool names that were there have gone:
slide 3's stack table already lists every one of them, so the strip was
spending the deck's last clear space on a repeat.

Two collisions surfaced while fitting it, both from a check that was
looking at the wrong rectangle. A rotated shape stores its PRE-rotation
box, so the pentagon banners -- built on their side and turned 90 degrees
-- were being audited as 1.98 wide by 2.35 tall when they render the
other way round. With the geometry read correctly, the lowest claim on
the impact ring sat 0.08" inside the footer band and the tech stack's
tenth row sat 0.06" inside it. Both moved.

Bounds, text fit, band collisions and caption overlap are all clean. They
are still estimates from font metrics, not a render.
</commit_message>
<xml_diff>
--- a/SIH2026_PS26153_Presentation.pptx
+++ b/SIH2026_PS26153_Presentation.pptx
@@ -9396,7 +9396,7 @@
         <p:spPr>
           <a:xfrm>
             <a:off x="7360920" y="1755648"/>
-            <a:ext cx="1931212" cy="365760"/>
+            <a:ext cx="1931212" cy="352044"/>
           </a:xfrm>
           <a:prstGeom prst="roundRect">
             <a:avLst/>
@@ -9449,7 +9449,7 @@
         <p:spPr>
           <a:xfrm>
             <a:off x="9356140" y="1755648"/>
-            <a:ext cx="2393899" cy="365760"/>
+            <a:ext cx="2393899" cy="352044"/>
           </a:xfrm>
           <a:prstGeom prst="roundRect">
             <a:avLst/>
@@ -9501,8 +9501,8 @@
         </p:nvSpPr>
         <p:spPr>
           <a:xfrm>
-            <a:off x="7360920" y="2171700"/>
-            <a:ext cx="1931212" cy="365760"/>
+            <a:off x="7360920" y="2157984"/>
+            <a:ext cx="1931212" cy="352044"/>
           </a:xfrm>
           <a:prstGeom prst="roundRect">
             <a:avLst/>
@@ -9554,8 +9554,8 @@
         </p:nvSpPr>
         <p:spPr>
           <a:xfrm>
-            <a:off x="9356140" y="2171700"/>
-            <a:ext cx="2393899" cy="365760"/>
+            <a:off x="9356140" y="2157984"/>
+            <a:ext cx="2393899" cy="352044"/>
           </a:xfrm>
           <a:prstGeom prst="roundRect">
             <a:avLst/>
@@ -9607,8 +9607,8 @@
         </p:nvSpPr>
         <p:spPr>
           <a:xfrm>
-            <a:off x="7360920" y="2587752"/>
-            <a:ext cx="1931212" cy="365760"/>
+            <a:off x="7360920" y="2560320"/>
+            <a:ext cx="1931212" cy="352044"/>
           </a:xfrm>
           <a:prstGeom prst="roundRect">
             <a:avLst/>
@@ -9660,8 +9660,8 @@
         </p:nvSpPr>
         <p:spPr>
           <a:xfrm>
-            <a:off x="9356140" y="2587752"/>
-            <a:ext cx="2393899" cy="365760"/>
+            <a:off x="9356140" y="2560320"/>
+            <a:ext cx="2393899" cy="352044"/>
           </a:xfrm>
           <a:prstGeom prst="roundRect">
             <a:avLst/>
@@ -9713,8 +9713,8 @@
         </p:nvSpPr>
         <p:spPr>
           <a:xfrm>
-            <a:off x="7360920" y="3003804"/>
-            <a:ext cx="1931212" cy="365760"/>
+            <a:off x="7360920" y="2962656"/>
+            <a:ext cx="1931212" cy="352044"/>
           </a:xfrm>
           <a:prstGeom prst="roundRect">
             <a:avLst/>
@@ -9766,8 +9766,8 @@
         </p:nvSpPr>
         <p:spPr>
           <a:xfrm>
-            <a:off x="9356140" y="3003804"/>
-            <a:ext cx="2393899" cy="365760"/>
+            <a:off x="9356140" y="2962656"/>
+            <a:ext cx="2393899" cy="352044"/>
           </a:xfrm>
           <a:prstGeom prst="roundRect">
             <a:avLst/>
@@ -9819,8 +9819,8 @@
         </p:nvSpPr>
         <p:spPr>
           <a:xfrm>
-            <a:off x="7360920" y="3419856"/>
-            <a:ext cx="1931212" cy="365760"/>
+            <a:off x="7360920" y="3364991"/>
+            <a:ext cx="1931212" cy="352044"/>
           </a:xfrm>
           <a:prstGeom prst="roundRect">
             <a:avLst/>
@@ -9872,8 +9872,8 @@
         </p:nvSpPr>
         <p:spPr>
           <a:xfrm>
-            <a:off x="9356140" y="3419856"/>
-            <a:ext cx="2393899" cy="365760"/>
+            <a:off x="9356140" y="3364991"/>
+            <a:ext cx="2393899" cy="352044"/>
           </a:xfrm>
           <a:prstGeom prst="roundRect">
             <a:avLst/>
@@ -9925,8 +9925,8 @@
         </p:nvSpPr>
         <p:spPr>
           <a:xfrm>
-            <a:off x="7360920" y="3835908"/>
-            <a:ext cx="1931212" cy="365760"/>
+            <a:off x="7360920" y="3767328"/>
+            <a:ext cx="1931212" cy="352044"/>
           </a:xfrm>
           <a:prstGeom prst="roundRect">
             <a:avLst/>
@@ -9978,8 +9978,8 @@
         </p:nvSpPr>
         <p:spPr>
           <a:xfrm>
-            <a:off x="9356140" y="3835908"/>
-            <a:ext cx="2393899" cy="365760"/>
+            <a:off x="9356140" y="3767328"/>
+            <a:ext cx="2393899" cy="352044"/>
           </a:xfrm>
           <a:prstGeom prst="roundRect">
             <a:avLst/>
@@ -10031,8 +10031,8 @@
         </p:nvSpPr>
         <p:spPr>
           <a:xfrm>
-            <a:off x="7360920" y="4251960"/>
-            <a:ext cx="1931212" cy="365760"/>
+            <a:off x="7360920" y="4169664"/>
+            <a:ext cx="1931212" cy="352044"/>
           </a:xfrm>
           <a:prstGeom prst="roundRect">
             <a:avLst/>
@@ -10084,8 +10084,8 @@
         </p:nvSpPr>
         <p:spPr>
           <a:xfrm>
-            <a:off x="9356140" y="4251960"/>
-            <a:ext cx="2393899" cy="365760"/>
+            <a:off x="9356140" y="4169664"/>
+            <a:ext cx="2393899" cy="352044"/>
           </a:xfrm>
           <a:prstGeom prst="roundRect">
             <a:avLst/>
@@ -10137,8 +10137,8 @@
         </p:nvSpPr>
         <p:spPr>
           <a:xfrm>
-            <a:off x="7360920" y="4668012"/>
-            <a:ext cx="1931212" cy="365760"/>
+            <a:off x="7360920" y="4572000"/>
+            <a:ext cx="1931212" cy="352044"/>
           </a:xfrm>
           <a:prstGeom prst="roundRect">
             <a:avLst/>
@@ -10190,8 +10190,8 @@
         </p:nvSpPr>
         <p:spPr>
           <a:xfrm>
-            <a:off x="9356140" y="4668012"/>
-            <a:ext cx="2393899" cy="365760"/>
+            <a:off x="9356140" y="4572000"/>
+            <a:ext cx="2393899" cy="352044"/>
           </a:xfrm>
           <a:prstGeom prst="roundRect">
             <a:avLst/>
@@ -10243,8 +10243,8 @@
         </p:nvSpPr>
         <p:spPr>
           <a:xfrm>
-            <a:off x="7360920" y="5084064"/>
-            <a:ext cx="1931212" cy="365760"/>
+            <a:off x="7360920" y="4974336"/>
+            <a:ext cx="1931212" cy="352044"/>
           </a:xfrm>
           <a:prstGeom prst="roundRect">
             <a:avLst/>
@@ -10296,8 +10296,8 @@
         </p:nvSpPr>
         <p:spPr>
           <a:xfrm>
-            <a:off x="9356140" y="5084064"/>
-            <a:ext cx="2393899" cy="365760"/>
+            <a:off x="9356140" y="4974336"/>
+            <a:ext cx="2393899" cy="352044"/>
           </a:xfrm>
           <a:prstGeom prst="roundRect">
             <a:avLst/>
@@ -10349,8 +10349,8 @@
         </p:nvSpPr>
         <p:spPr>
           <a:xfrm>
-            <a:off x="7360920" y="5500116"/>
-            <a:ext cx="1931212" cy="365760"/>
+            <a:off x="7360920" y="5376672"/>
+            <a:ext cx="1931212" cy="352044"/>
           </a:xfrm>
           <a:prstGeom prst="roundRect">
             <a:avLst/>
@@ -10402,8 +10402,8 @@
         </p:nvSpPr>
         <p:spPr>
           <a:xfrm>
-            <a:off x="9356140" y="5500116"/>
-            <a:ext cx="2393899" cy="365760"/>
+            <a:off x="9356140" y="5376672"/>
+            <a:ext cx="2393899" cy="352044"/>
           </a:xfrm>
           <a:prstGeom prst="roundRect">
             <a:avLst/>
@@ -14260,7 +14260,7 @@
         </p:nvSpPr>
         <p:spPr>
           <a:xfrm>
-            <a:off x="8165592" y="3200400"/>
+            <a:off x="8165592" y="3127248"/>
             <a:ext cx="1682496" cy="1682496"/>
           </a:xfrm>
           <a:prstGeom prst="donut">
@@ -14302,7 +14302,7 @@
         </p:nvSpPr>
         <p:spPr>
           <a:xfrm>
-            <a:off x="8869680" y="3181014"/>
+            <a:off x="8869680" y="3107862"/>
             <a:ext cx="274320" cy="274320"/>
           </a:xfrm>
           <a:prstGeom prst="ellipse">
@@ -14355,7 +14355,7 @@
         </p:nvSpPr>
         <p:spPr>
           <a:xfrm>
-            <a:off x="8147304" y="2212848"/>
+            <a:off x="8147304" y="2231136"/>
             <a:ext cx="1719072" cy="566928"/>
           </a:xfrm>
           <a:prstGeom prst="rect">
@@ -14406,7 +14406,7 @@
         </p:nvSpPr>
         <p:spPr>
           <a:xfrm>
-            <a:off x="9496226" y="3542751"/>
+            <a:off x="9496226" y="3469599"/>
             <a:ext cx="274320" cy="274320"/>
           </a:xfrm>
           <a:prstGeom prst="ellipse">
@@ -14459,7 +14459,7 @@
         </p:nvSpPr>
         <p:spPr>
           <a:xfrm>
-            <a:off x="9936983" y="2990088"/>
+            <a:off x="9936983" y="2962656"/>
             <a:ext cx="1719072" cy="566928"/>
           </a:xfrm>
           <a:prstGeom prst="rect">
@@ -14510,7 +14510,7 @@
         </p:nvSpPr>
         <p:spPr>
           <a:xfrm>
-            <a:off x="9496226" y="4266224"/>
+            <a:off x="9496226" y="4193072"/>
             <a:ext cx="274320" cy="274320"/>
           </a:xfrm>
           <a:prstGeom prst="ellipse">
@@ -14563,7 +14563,7 @@
         </p:nvSpPr>
         <p:spPr>
           <a:xfrm>
-            <a:off x="9936983" y="4544568"/>
+            <a:off x="9936983" y="4425696"/>
             <a:ext cx="1719072" cy="566928"/>
           </a:xfrm>
           <a:prstGeom prst="rect">
@@ -14614,7 +14614,7 @@
         </p:nvSpPr>
         <p:spPr>
           <a:xfrm>
-            <a:off x="8869680" y="4627961"/>
+            <a:off x="8869680" y="4554809"/>
             <a:ext cx="274320" cy="274320"/>
           </a:xfrm>
           <a:prstGeom prst="ellipse">
@@ -14667,7 +14667,7 @@
         </p:nvSpPr>
         <p:spPr>
           <a:xfrm>
-            <a:off x="8147304" y="5321808"/>
+            <a:off x="8147304" y="5157216"/>
             <a:ext cx="1719072" cy="566928"/>
           </a:xfrm>
           <a:prstGeom prst="rect">
@@ -14718,7 +14718,7 @@
         </p:nvSpPr>
         <p:spPr>
           <a:xfrm>
-            <a:off x="8243133" y="4266224"/>
+            <a:off x="8243133" y="4193072"/>
             <a:ext cx="274320" cy="274320"/>
           </a:xfrm>
           <a:prstGeom prst="ellipse">
@@ -14771,7 +14771,7 @@
         </p:nvSpPr>
         <p:spPr>
           <a:xfrm>
-            <a:off x="6357624" y="4544568"/>
+            <a:off x="6357624" y="4425696"/>
             <a:ext cx="1719072" cy="566928"/>
           </a:xfrm>
           <a:prstGeom prst="rect">
@@ -14822,7 +14822,7 @@
         </p:nvSpPr>
         <p:spPr>
           <a:xfrm>
-            <a:off x="8243133" y="3542751"/>
+            <a:off x="8243133" y="3469599"/>
             <a:ext cx="274320" cy="274320"/>
           </a:xfrm>
           <a:prstGeom prst="ellipse">
@@ -14875,7 +14875,7 @@
         </p:nvSpPr>
         <p:spPr>
           <a:xfrm>
-            <a:off x="6357624" y="2990087"/>
+            <a:off x="6357624" y="2962656"/>
             <a:ext cx="1719072" cy="566928"/>
           </a:xfrm>
           <a:prstGeom prst="rect">
@@ -16636,7 +16636,7 @@
         </p:nvSpPr>
         <p:spPr>
           <a:xfrm>
-            <a:off x="411480" y="4443983"/>
+            <a:off x="411480" y="4261104"/>
             <a:ext cx="11338560" cy="256032"/>
           </a:xfrm>
           <a:prstGeom prst="rect">
@@ -16658,7 +16658,7 @@
                 </a:solidFill>
                 <a:latin typeface="Arial"/>
               </a:rPr>
-              <a:t>Built with</a:t>
+              <a:t>Team - Git with It</a:t>
             </a:r>
           </a:p>
         </p:txBody>
@@ -16671,7 +16671,7 @@
         </p:nvSpPr>
         <p:spPr>
           <a:xfrm>
-            <a:off x="448056" y="4700016"/>
+            <a:off x="448056" y="4517136"/>
             <a:ext cx="11265408" cy="32004"/>
           </a:xfrm>
           <a:prstGeom prst="rect">
@@ -16713,8 +16713,8 @@
         </p:nvSpPr>
         <p:spPr>
           <a:xfrm>
-            <a:off x="411480" y="4882896"/>
-            <a:ext cx="1541417" cy="621792"/>
+            <a:off x="411480" y="4681728"/>
+            <a:ext cx="1813560" cy="621792"/>
           </a:xfrm>
           <a:prstGeom prst="foldedCorner">
             <a:avLst/>
@@ -16747,13 +16747,25 @@
           <a:p>
             <a:pPr algn="ctr"/>
             <a:r>
-              <a:rPr sz="800" b="1">
+              <a:rPr sz="900" b="1">
                 <a:solidFill>
                   <a:srgbClr val="FFFFFF"/>
                 </a:solidFill>
                 <a:latin typeface="Arial"/>
               </a:rPr>
-              <a:t>Python 3.13</a:t>
+              <a:t>Suyash Shukla</a:t>
+            </a:r>
+          </a:p>
+          <a:p>
+            <a:pPr algn="ctr"/>
+            <a:r>
+              <a:rPr sz="700" b="0">
+                <a:solidFill>
+                  <a:srgbClr val="FFFFFF"/>
+                </a:solidFill>
+                <a:latin typeface="Arial"/>
+              </a:rPr>
+              <a:t>Team Leader</a:t>
             </a:r>
           </a:p>
         </p:txBody>
@@ -16766,8 +16778,8 @@
         </p:nvSpPr>
         <p:spPr>
           <a:xfrm>
-            <a:off x="2044337" y="4882896"/>
-            <a:ext cx="1541417" cy="621792"/>
+            <a:off x="2316480" y="4681728"/>
+            <a:ext cx="1813560" cy="621792"/>
           </a:xfrm>
           <a:prstGeom prst="foldedCorner">
             <a:avLst/>
@@ -16800,13 +16812,25 @@
           <a:p>
             <a:pPr algn="ctr"/>
             <a:r>
-              <a:rPr sz="800" b="1">
+              <a:rPr sz="900" b="1">
                 <a:solidFill>
                   <a:srgbClr val="FFFFFF"/>
                 </a:solidFill>
                 <a:latin typeface="Arial"/>
               </a:rPr>
-              <a:t>PyTorch</a:t>
+              <a:t>Tanmay Kumar Sinha</a:t>
+            </a:r>
+          </a:p>
+          <a:p>
+            <a:pPr algn="ctr"/>
+            <a:r>
+              <a:rPr sz="700" b="0">
+                <a:solidFill>
+                  <a:srgbClr val="FFFFFF"/>
+                </a:solidFill>
+                <a:latin typeface="Arial"/>
+              </a:rPr>
+              <a:t>Member</a:t>
             </a:r>
           </a:p>
         </p:txBody>
@@ -16819,8 +16843,8 @@
         </p:nvSpPr>
         <p:spPr>
           <a:xfrm>
-            <a:off x="3677194" y="4882896"/>
-            <a:ext cx="1541417" cy="621792"/>
+            <a:off x="4221480" y="4681728"/>
+            <a:ext cx="1813560" cy="621792"/>
           </a:xfrm>
           <a:prstGeom prst="foldedCorner">
             <a:avLst/>
@@ -16853,13 +16877,25 @@
           <a:p>
             <a:pPr algn="ctr"/>
             <a:r>
-              <a:rPr sz="800" b="1">
+              <a:rPr sz="900" b="1">
                 <a:solidFill>
                   <a:srgbClr val="FFFFFF"/>
                 </a:solidFill>
                 <a:latin typeface="Arial"/>
               </a:rPr>
-              <a:t>Scapy</a:t>
+              <a:t>Shivam Kumar Tripathi</a:t>
+            </a:r>
+          </a:p>
+          <a:p>
+            <a:pPr algn="ctr"/>
+            <a:r>
+              <a:rPr sz="700" b="0">
+                <a:solidFill>
+                  <a:srgbClr val="FFFFFF"/>
+                </a:solidFill>
+                <a:latin typeface="Arial"/>
+              </a:rPr>
+              <a:t>Member</a:t>
             </a:r>
           </a:p>
         </p:txBody>
@@ -16872,8 +16908,8 @@
         </p:nvSpPr>
         <p:spPr>
           <a:xfrm>
-            <a:off x="5310051" y="4882896"/>
-            <a:ext cx="1541417" cy="621792"/>
+            <a:off x="6126480" y="4681728"/>
+            <a:ext cx="1813560" cy="621792"/>
           </a:xfrm>
           <a:prstGeom prst="foldedCorner">
             <a:avLst/>
@@ -16906,13 +16942,25 @@
           <a:p>
             <a:pPr algn="ctr"/>
             <a:r>
-              <a:rPr sz="800" b="1">
+              <a:rPr sz="900" b="1">
                 <a:solidFill>
                   <a:srgbClr val="FFFFFF"/>
                 </a:solidFill>
                 <a:latin typeface="Arial"/>
               </a:rPr>
-              <a:t>pandas + NumPy</a:t>
+              <a:t>Tanay</a:t>
+            </a:r>
+          </a:p>
+          <a:p>
+            <a:pPr algn="ctr"/>
+            <a:r>
+              <a:rPr sz="700" b="0">
+                <a:solidFill>
+                  <a:srgbClr val="FFFFFF"/>
+                </a:solidFill>
+                <a:latin typeface="Arial"/>
+              </a:rPr>
+              <a:t>Member</a:t>
             </a:r>
           </a:p>
         </p:txBody>
@@ -16925,8 +16973,8 @@
         </p:nvSpPr>
         <p:spPr>
           <a:xfrm>
-            <a:off x="6942908" y="4882896"/>
-            <a:ext cx="1541417" cy="621792"/>
+            <a:off x="8031480" y="4681728"/>
+            <a:ext cx="1813560" cy="621792"/>
           </a:xfrm>
           <a:prstGeom prst="foldedCorner">
             <a:avLst/>
@@ -16959,13 +17007,25 @@
           <a:p>
             <a:pPr algn="ctr"/>
             <a:r>
-              <a:rPr sz="800" b="1">
+              <a:rPr sz="900" b="1">
                 <a:solidFill>
                   <a:srgbClr val="FFFFFF"/>
                 </a:solidFill>
                 <a:latin typeface="Arial"/>
               </a:rPr>
-              <a:t>scikit-learn</a:t>
+              <a:t>Yuvan Laxmanan</a:t>
+            </a:r>
+          </a:p>
+          <a:p>
+            <a:pPr algn="ctr"/>
+            <a:r>
+              <a:rPr sz="700" b="0">
+                <a:solidFill>
+                  <a:srgbClr val="FFFFFF"/>
+                </a:solidFill>
+                <a:latin typeface="Arial"/>
+              </a:rPr>
+              <a:t>Member</a:t>
             </a:r>
           </a:p>
         </p:txBody>
@@ -16978,8 +17038,8 @@
         </p:nvSpPr>
         <p:spPr>
           <a:xfrm>
-            <a:off x="8575765" y="4882896"/>
-            <a:ext cx="1541417" cy="621792"/>
+            <a:off x="9936480" y="4681728"/>
+            <a:ext cx="1813560" cy="621792"/>
           </a:xfrm>
           <a:prstGeom prst="foldedCorner">
             <a:avLst/>
@@ -17012,73 +17072,32 @@
           <a:p>
             <a:pPr algn="ctr"/>
             <a:r>
-              <a:rPr sz="800" b="1">
+              <a:rPr sz="900" b="1">
                 <a:solidFill>
                   <a:srgbClr val="FFFFFF"/>
                 </a:solidFill>
                 <a:latin typeface="Arial"/>
               </a:rPr>
-              <a:t>FastAPI</a:t>
-            </a:r>
-          </a:p>
-        </p:txBody>
-      </p:sp>
-      <p:sp>
-        <p:nvSpPr>
-          <p:cNvPr id="17441" name="Folded Corner 17440"/>
-          <p:cNvSpPr/>
-          <p:nvPr/>
-        </p:nvSpPr>
-        <p:spPr>
-          <a:xfrm>
-            <a:off x="10208622" y="4882896"/>
-            <a:ext cx="1541417" cy="621792"/>
-          </a:xfrm>
-          <a:prstGeom prst="foldedCorner">
-            <a:avLst/>
-          </a:prstGeom>
-          <a:solidFill>
-            <a:srgbClr val="4F81BD"/>
-          </a:solidFill>
-          <a:ln>
-            <a:noFill/>
-          </a:ln>
-          <a:effectLst/>
-        </p:spPr>
-        <p:style>
-          <a:lnRef idx="1">
-            <a:schemeClr val="accent1"/>
-          </a:lnRef>
-          <a:fillRef idx="3">
-            <a:schemeClr val="accent1"/>
-          </a:fillRef>
-          <a:effectRef idx="2">
-            <a:schemeClr val="accent1"/>
-          </a:effectRef>
-          <a:fontRef idx="minor">
-            <a:schemeClr val="lt1"/>
-          </a:fontRef>
-        </p:style>
-        <p:txBody>
-          <a:bodyPr rtlCol="0" anchor="ctr" wrap="square" lIns="50800" rIns="50800" tIns="25400" bIns="25400"/>
-          <a:lstStyle/>
+              <a:t>Vaishnavi Tripathi</a:t>
+            </a:r>
+          </a:p>
           <a:p>
             <a:pPr algn="ctr"/>
             <a:r>
-              <a:rPr sz="800" b="1">
+              <a:rPr sz="700" b="0">
                 <a:solidFill>
                   <a:srgbClr val="FFFFFF"/>
                 </a:solidFill>
                 <a:latin typeface="Arial"/>
               </a:rPr>
-              <a:t>Integrated Gradients</a:t>
-            </a:r>
-          </a:p>
-        </p:txBody>
-      </p:sp>
-      <p:sp>
-        <p:nvSpPr>
-          <p:cNvPr id="17442" name="Rounded Rectangle 17441"/>
+              <a:t>Member</a:t>
+            </a:r>
+          </a:p>
+        </p:txBody>
+      </p:sp>
+      <p:sp>
+        <p:nvSpPr>
+          <p:cNvPr id="17441" name="Rounded Rectangle 17440"/>
           <p:cNvSpPr/>
           <p:nvPr/>
         </p:nvSpPr>
@@ -17131,7 +17150,7 @@
       </p:sp>
       <p:sp>
         <p:nvSpPr>
-          <p:cNvPr id="17443" name="Rounded Rectangle 17442"/>
+          <p:cNvPr id="17442" name="Rounded Rectangle 17441"/>
           <p:cNvSpPr/>
           <p:nvPr/>
         </p:nvSpPr>

</xml_diff>

<commit_message>
Make the team name readable, and leave a slot for the logo
On the deck the name sat as the template ships it -- 9pt, unbolded, theme
colour on a transparent oval -- which on a projector reads as a
watermark rather than as whose work this is. It is a badge now: filled,
navy outline, 11pt bold, on all five content slides.

On the dashboard it was not there at all. Same badge treatment in the
sidebar, under the title.

The brand mark is still the placeholder diamond, but it now swaps itself
for static/logo.png the moment that file exists -- dropping the image in
is the whole install step, no edit needed.
</commit_message>
<xml_diff>
--- a/SIH2026_PS26153_Presentation.pptx
+++ b/SIH2026_PS26153_Presentation.pptx
@@ -6104,6 +6104,15 @@
           <a:prstGeom prst="ellipse">
             <a:avLst/>
           </a:prstGeom>
+          <a:solidFill>
+            <a:srgbClr val="F2F5FA"/>
+          </a:solidFill>
+          <a:ln w="19050">
+            <a:solidFill>
+              <a:srgbClr val="1F497D"/>
+            </a:solidFill>
+          </a:ln>
+          <a:effectLst/>
         </p:spPr>
         <p:style>
           <a:lnRef idx="2">
@@ -6125,7 +6134,12 @@
           <a:p>
             <a:pPr algn="ctr"/>
             <a:r>
-              <a:rPr lang="en-US" dirty="0" sz="900"/>
+              <a:rPr lang="en-US" dirty="0" sz="1100" b="1">
+                <a:solidFill>
+                  <a:srgbClr val="1F497D"/>
+                </a:solidFill>
+                <a:latin typeface="Arial"/>
+              </a:rPr>
               <a:t>Git with It</a:t>
             </a:r>
             <a:endParaRPr lang="en-IN" dirty="0"/>
@@ -8468,6 +8482,15 @@
           <a:prstGeom prst="ellipse">
             <a:avLst/>
           </a:prstGeom>
+          <a:solidFill>
+            <a:srgbClr val="F2F5FA"/>
+          </a:solidFill>
+          <a:ln w="19050">
+            <a:solidFill>
+              <a:srgbClr val="1F497D"/>
+            </a:solidFill>
+          </a:ln>
+          <a:effectLst/>
         </p:spPr>
         <p:style>
           <a:lnRef idx="2">
@@ -8489,7 +8512,12 @@
           <a:p>
             <a:pPr algn="ctr"/>
             <a:r>
-              <a:rPr lang="en-US" dirty="0" sz="900"/>
+              <a:rPr lang="en-US" dirty="0" sz="1100" b="1">
+                <a:solidFill>
+                  <a:srgbClr val="1F497D"/>
+                </a:solidFill>
+                <a:latin typeface="Arial"/>
+              </a:rPr>
               <a:t>Git with It</a:t>
             </a:r>
             <a:endParaRPr lang="en-IN" dirty="0"/>
@@ -10872,6 +10900,15 @@
           <a:prstGeom prst="ellipse">
             <a:avLst/>
           </a:prstGeom>
+          <a:solidFill>
+            <a:srgbClr val="F2F5FA"/>
+          </a:solidFill>
+          <a:ln w="19050">
+            <a:solidFill>
+              <a:srgbClr val="1F497D"/>
+            </a:solidFill>
+          </a:ln>
+          <a:effectLst/>
         </p:spPr>
         <p:style>
           <a:lnRef idx="2">
@@ -10893,7 +10930,12 @@
           <a:p>
             <a:pPr algn="ctr"/>
             <a:r>
-              <a:rPr lang="en-US" dirty="0" sz="900"/>
+              <a:rPr lang="en-US" dirty="0" sz="1100" b="1">
+                <a:solidFill>
+                  <a:srgbClr val="1F497D"/>
+                </a:solidFill>
+                <a:latin typeface="Arial"/>
+              </a:rPr>
               <a:t>Git with It</a:t>
             </a:r>
             <a:endParaRPr lang="en-IN" dirty="0"/>
@@ -13422,6 +13464,15 @@
           <a:prstGeom prst="ellipse">
             <a:avLst/>
           </a:prstGeom>
+          <a:solidFill>
+            <a:srgbClr val="F2F5FA"/>
+          </a:solidFill>
+          <a:ln w="19050">
+            <a:solidFill>
+              <a:srgbClr val="1F497D"/>
+            </a:solidFill>
+          </a:ln>
+          <a:effectLst/>
         </p:spPr>
         <p:style>
           <a:lnRef idx="2">
@@ -13443,7 +13494,12 @@
           <a:p>
             <a:pPr algn="ctr"/>
             <a:r>
-              <a:rPr lang="en-US" dirty="0" sz="900"/>
+              <a:rPr lang="en-US" dirty="0" sz="1100" b="1">
+                <a:solidFill>
+                  <a:srgbClr val="1F497D"/>
+                </a:solidFill>
+                <a:latin typeface="Arial"/>
+              </a:rPr>
               <a:t>Git with It</a:t>
             </a:r>
             <a:endParaRPr lang="en-IN" dirty="0"/>
@@ -15348,6 +15404,15 @@
           <a:prstGeom prst="ellipse">
             <a:avLst/>
           </a:prstGeom>
+          <a:solidFill>
+            <a:srgbClr val="F2F5FA"/>
+          </a:solidFill>
+          <a:ln w="19050">
+            <a:solidFill>
+              <a:srgbClr val="1F497D"/>
+            </a:solidFill>
+          </a:ln>
+          <a:effectLst/>
         </p:spPr>
         <p:style>
           <a:lnRef idx="2">
@@ -15369,7 +15434,12 @@
           <a:p>
             <a:pPr algn="ctr"/>
             <a:r>
-              <a:rPr lang="en-US" dirty="0" sz="900"/>
+              <a:rPr lang="en-US" dirty="0" sz="1100" b="1">
+                <a:solidFill>
+                  <a:srgbClr val="1F497D"/>
+                </a:solidFill>
+                <a:latin typeface="Arial"/>
+              </a:rPr>
               <a:t>Git with It</a:t>
             </a:r>
             <a:endParaRPr lang="en-IN" dirty="0"/>

</xml_diff>

<commit_message>
Update the deck to the version the PDF was rendered from
The .pptx was held open by a viewer through the last few rounds, so the
fixes those rounds found - the chain claims moved inside their links, the
cropped topology screenshot, the table off the footer - reached the PDF
but not the deck itself. Same file now, verified by hash.
</commit_message>
<xml_diff>
--- a/SIH2026_PS26153_Presentation.pptx
+++ b/SIH2026_PS26153_Presentation.pptx
@@ -7912,7 +7912,7 @@
         <p:spPr>
           <a:xfrm>
             <a:off x="6309360" y="4617720"/>
-            <a:ext cx="1959863" cy="457200"/>
+            <a:ext cx="1911095" cy="457200"/>
           </a:xfrm>
           <a:prstGeom prst="roundRect">
             <a:avLst/>
@@ -7940,9 +7940,20 @@
           </a:fontRef>
         </p:style>
         <p:txBody>
-          <a:bodyPr rtlCol="0" anchor="ctr"/>
-          <a:lstStyle/>
-          <a:p/>
+          <a:bodyPr rtlCol="0" anchor="ctr" wrap="square" lIns="50800" rIns="50800" tIns="25400" bIns="25400"/>
+          <a:lstStyle/>
+          <a:p>
+            <a:pPr algn="ctr"/>
+            <a:r>
+              <a:rPr sz="800" b="1">
+                <a:solidFill>
+                  <a:srgbClr val="E37B2A"/>
+                </a:solidFill>
+                <a:latin typeface="Arial"/>
+              </a:rPr>
+              <a:t>World model, not a classifier</a:t>
+            </a:r>
+          </a:p>
         </p:txBody>
       </p:sp>
       <p:sp>
@@ -7953,8 +7964,8 @@
         </p:nvSpPr>
         <p:spPr>
           <a:xfrm>
-            <a:off x="6492240" y="5120640"/>
-            <a:ext cx="1594103" cy="658368"/>
+            <a:off x="6437376" y="5129783"/>
+            <a:ext cx="1655063" cy="566928"/>
           </a:xfrm>
           <a:prstGeom prst="rect">
             <a:avLst/>
@@ -7969,25 +7980,9 @@
           <a:p>
             <a:pPr algn="ctr"/>
             <a:r>
-              <a:rPr sz="800" b="1">
-                <a:solidFill>
-                  <a:srgbClr val="E37B2A"/>
-                </a:solidFill>
-                <a:latin typeface="Arial"/>
-              </a:rPr>
-              <a:t>World model, not a classifier</a:t>
-            </a:r>
-          </a:p>
-          <a:p>
-            <a:pPr algn="ctr">
-              <a:spcBef>
-                <a:spcPts val="100"/>
-              </a:spcBef>
-            </a:pPr>
-            <a:r>
-              <a:rPr sz="700" b="0">
-                <a:solidFill>
-                  <a:srgbClr val="E37B2A"/>
+              <a:rPr sz="750" b="0">
+                <a:solidFill>
+                  <a:srgbClr val="5A6478"/>
                 </a:solidFill>
                 <a:latin typeface="Arial"/>
               </a:rPr>
@@ -8004,8 +7999,8 @@
         </p:nvSpPr>
         <p:spPr>
           <a:xfrm>
-            <a:off x="8049767" y="4617720"/>
-            <a:ext cx="1959863" cy="457200"/>
+            <a:off x="8074152" y="4617720"/>
+            <a:ext cx="1911095" cy="457200"/>
           </a:xfrm>
           <a:prstGeom prst="roundRect">
             <a:avLst/>
@@ -8033,9 +8028,20 @@
           </a:fontRef>
         </p:style>
         <p:txBody>
-          <a:bodyPr rtlCol="0" anchor="ctr"/>
-          <a:lstStyle/>
-          <a:p/>
+          <a:bodyPr rtlCol="0" anchor="ctr" wrap="square" lIns="50800" rIns="50800" tIns="25400" bIns="25400"/>
+          <a:lstStyle/>
+          <a:p>
+            <a:pPr algn="ctr"/>
+            <a:r>
+              <a:rPr sz="800" b="1">
+                <a:solidFill>
+                  <a:srgbClr val="7A45D1"/>
+                </a:solidFill>
+                <a:latin typeface="Arial"/>
+              </a:rPr>
+              <a:t>Falsifiable by construction</a:t>
+            </a:r>
+          </a:p>
         </p:txBody>
       </p:sp>
       <p:sp>
@@ -8046,8 +8052,8 @@
         </p:nvSpPr>
         <p:spPr>
           <a:xfrm>
-            <a:off x="8232647" y="5120640"/>
-            <a:ext cx="1594103" cy="658368"/>
+            <a:off x="8202168" y="5129783"/>
+            <a:ext cx="1655063" cy="566928"/>
           </a:xfrm>
           <a:prstGeom prst="rect">
             <a:avLst/>
@@ -8062,25 +8068,9 @@
           <a:p>
             <a:pPr algn="ctr"/>
             <a:r>
-              <a:rPr sz="800" b="1">
-                <a:solidFill>
-                  <a:srgbClr val="7A45D1"/>
-                </a:solidFill>
-                <a:latin typeface="Arial"/>
-              </a:rPr>
-              <a:t>Falsifiable by construction</a:t>
-            </a:r>
-          </a:p>
-          <a:p>
-            <a:pPr algn="ctr">
-              <a:spcBef>
-                <a:spcPts val="100"/>
-              </a:spcBef>
-            </a:pPr>
-            <a:r>
-              <a:rPr sz="700" b="0">
-                <a:solidFill>
-                  <a:srgbClr val="7A45D1"/>
+              <a:rPr sz="750" b="0">
+                <a:solidFill>
+                  <a:srgbClr val="5A6478"/>
                 </a:solidFill>
                 <a:latin typeface="Arial"/>
               </a:rPr>
@@ -8097,8 +8087,8 @@
         </p:nvSpPr>
         <p:spPr>
           <a:xfrm>
-            <a:off x="9790176" y="4617720"/>
-            <a:ext cx="1959863" cy="457200"/>
+            <a:off x="9838944" y="4617720"/>
+            <a:ext cx="1911095" cy="457200"/>
           </a:xfrm>
           <a:prstGeom prst="roundRect">
             <a:avLst/>
@@ -8126,9 +8116,20 @@
           </a:fontRef>
         </p:style>
         <p:txBody>
-          <a:bodyPr rtlCol="0" anchor="ctr"/>
-          <a:lstStyle/>
-          <a:p/>
+          <a:bodyPr rtlCol="0" anchor="ctr" wrap="square" lIns="50800" rIns="50800" tIns="25400" bIns="25400"/>
+          <a:lstStyle/>
+          <a:p>
+            <a:pPr algn="ctr"/>
+            <a:r>
+              <a:rPr sz="800" b="1">
+                <a:solidFill>
+                  <a:srgbClr val="77933C"/>
+                </a:solidFill>
+                <a:latin typeface="Arial"/>
+              </a:rPr>
+              <a:t>Runs offline on a CPU</a:t>
+            </a:r>
+          </a:p>
         </p:txBody>
       </p:sp>
       <p:sp>
@@ -8139,8 +8140,8 @@
         </p:nvSpPr>
         <p:spPr>
           <a:xfrm>
-            <a:off x="9973056" y="5120640"/>
-            <a:ext cx="1594103" cy="658368"/>
+            <a:off x="9966960" y="5129783"/>
+            <a:ext cx="1655063" cy="566928"/>
           </a:xfrm>
           <a:prstGeom prst="rect">
             <a:avLst/>
@@ -8155,25 +8156,9 @@
           <a:p>
             <a:pPr algn="ctr"/>
             <a:r>
-              <a:rPr sz="800" b="1">
-                <a:solidFill>
-                  <a:srgbClr val="77933C"/>
-                </a:solidFill>
-                <a:latin typeface="Arial"/>
-              </a:rPr>
-              <a:t>Runs offline on a CPU</a:t>
-            </a:r>
-          </a:p>
-          <a:p>
-            <a:pPr algn="ctr">
-              <a:spcBef>
-                <a:spcPts val="100"/>
-              </a:spcBef>
-            </a:pPr>
-            <a:r>
-              <a:rPr sz="700" b="0">
-                <a:solidFill>
-                  <a:srgbClr val="77933C"/>
+              <a:rPr sz="750" b="0">
+                <a:solidFill>
+                  <a:srgbClr val="5A6478"/>
                 </a:solidFill>
                 <a:latin typeface="Arial"/>
               </a:rPr>
@@ -11593,7 +11578,7 @@
       </p:sp>
       <p:pic>
         <p:nvPicPr>
-          <p:cNvPr id="17425" name="Picture 17424" descr="g-topology.png"/>
+          <p:cNvPr id="17425" name="Picture 17424" descr="g-topology-crop.png"/>
           <p:cNvPicPr>
             <a:picLocks noChangeAspect="1"/>
           </p:cNvPicPr>
@@ -11607,8 +11592,8 @@
         </p:blipFill>
         <p:spPr>
           <a:xfrm>
-            <a:off x="1356890" y="3474720"/>
-            <a:ext cx="3595579" cy="2432304"/>
+            <a:off x="1194216" y="3474720"/>
+            <a:ext cx="3920927" cy="2432304"/>
           </a:xfrm>
           <a:prstGeom prst="rect">
             <a:avLst/>
@@ -12676,7 +12661,7 @@
         </p:nvSpPr>
         <p:spPr>
           <a:xfrm>
-            <a:off x="6263640" y="5285231"/>
+            <a:off x="6263640" y="5010912"/>
             <a:ext cx="5486399" cy="402336"/>
           </a:xfrm>
           <a:prstGeom prst="roundRect">
@@ -12730,8 +12715,8 @@
           <p:nvPr/>
         </p:nvGraphicFramePr>
         <p:xfrm>
-          <a:off x="6263640" y="5705856"/>
-          <a:ext cx="5522976" cy="512064"/>
+          <a:off x="6263640" y="5431536"/>
+          <a:ext cx="5522976" cy="603504"/>
         </p:xfrm>
         <a:graphic>
           <a:graphicData uri="http://schemas.openxmlformats.org/drawingml/2006/table">
@@ -12746,7 +12731,7 @@
                 <a:gridCol w="877824"/>
                 <a:gridCol w="877824"/>
               </a:tblGrid>
-              <a:tr h="170688">
+              <a:tr h="201168">
                 <a:tc>
                   <a:txBody>
                     <a:bodyPr wrap="square"/>
@@ -12863,7 +12848,7 @@
                   </a:tcPr>
                 </a:tc>
               </a:tr>
-              <a:tr h="170688">
+              <a:tr h="201168">
                 <a:tc>
                   <a:txBody>
                     <a:bodyPr wrap="square"/>
@@ -12980,7 +12965,7 @@
                   </a:tcPr>
                 </a:tc>
               </a:tr>
-              <a:tr h="170688">
+              <a:tr h="201168">
                 <a:tc>
                   <a:txBody>
                     <a:bodyPr wrap="square"/>

</xml_diff>